<commit_message>
changement titre cours 3
</commit_message>
<xml_diff>
--- a/Cours_3/Cours programmation WEB3.pptx
+++ b/Cours_3/Cours programmation WEB3.pptx
@@ -114,6 +114,11 @@
       </a:defRPr>
     </a:lvl9pPr>
   </p:defaultTextStyle>
+  <p:extLst>
+    <p:ext uri="{EFAFB233-063F-42B5-8137-9DF3F51BA10A}">
+      <p15:sldGuideLst xmlns:p15="http://schemas.microsoft.com/office/powerpoint/2012/main"/>
+    </p:ext>
+  </p:extLst>
 </p:presentation>
 </file>
 
@@ -4564,7 +4569,7 @@
             <a:pPr algn="ctr"/>
             <a:r>
               <a:rPr lang="fr-FR" sz="6600" dirty="0"/>
-              <a:t>RECAPITULATIF</a:t>
+              <a:t>COURS WEB 3</a:t>
             </a:r>
             <a:endParaRPr lang="fr-FR" dirty="0"/>
           </a:p>

</xml_diff>